<commit_message>
Atualiza pitch para PDF certo
</commit_message>
<xml_diff>
--- a/docs/Escrow_Freelancer_Pitch.pptx
+++ b/docs/Escrow_Freelancer_Pitch.pptx
@@ -1189,7 +1189,7 @@
           <a:p>
             <a:fld id="{4AAD347D-5ACD-4C99-B74B-A9C85AD731AF}" type="datetimeFigureOut">
               <a:rPr lang="en-US" smtClean="0"/>
-              <a:t>6/7/2026</a:t>
+              <a:t>6/8/2026</a:t>
             </a:fld>
             <a:endParaRPr lang="en-US" dirty="0"/>
           </a:p>
@@ -1488,7 +1488,7 @@
           <a:p>
             <a:fld id="{4509A250-FF31-4206-8172-F9D3106AACB1}" type="datetimeFigureOut">
               <a:rPr lang="en-US" smtClean="0"/>
-              <a:t>6/7/2026</a:t>
+              <a:t>6/8/2026</a:t>
             </a:fld>
             <a:endParaRPr lang="en-US" dirty="0"/>
           </a:p>
@@ -1681,7 +1681,7 @@
           <a:p>
             <a:fld id="{4509A250-FF31-4206-8172-F9D3106AACB1}" type="datetimeFigureOut">
               <a:rPr lang="en-US" smtClean="0"/>
-              <a:t>6/7/2026</a:t>
+              <a:t>6/8/2026</a:t>
             </a:fld>
             <a:endParaRPr lang="en-US" dirty="0"/>
           </a:p>
@@ -1943,7 +1943,7 @@
           <a:p>
             <a:fld id="{4AAD347D-5ACD-4C99-B74B-A9C85AD731AF}" type="datetimeFigureOut">
               <a:rPr lang="en-US" smtClean="0"/>
-              <a:t>6/7/2026</a:t>
+              <a:t>6/8/2026</a:t>
             </a:fld>
             <a:endParaRPr lang="en-US" dirty="0"/>
           </a:p>
@@ -2368,7 +2368,7 @@
           <a:p>
             <a:fld id="{4AAD347D-5ACD-4C99-B74B-A9C85AD731AF}" type="datetimeFigureOut">
               <a:rPr lang="en-US" smtClean="0"/>
-              <a:t>6/7/2026</a:t>
+              <a:t>6/8/2026</a:t>
             </a:fld>
             <a:endParaRPr lang="en-US" dirty="0"/>
           </a:p>
@@ -2906,7 +2906,7 @@
           <a:p>
             <a:fld id="{4509A250-FF31-4206-8172-F9D3106AACB1}" type="datetimeFigureOut">
               <a:rPr lang="en-US" smtClean="0"/>
-              <a:t>6/7/2026</a:t>
+              <a:t>6/8/2026</a:t>
             </a:fld>
             <a:endParaRPr lang="en-US" dirty="0"/>
           </a:p>
@@ -3771,7 +3771,7 @@
           <a:p>
             <a:fld id="{4509A250-FF31-4206-8172-F9D3106AACB1}" type="datetimeFigureOut">
               <a:rPr lang="en-US" smtClean="0"/>
-              <a:t>6/7/2026</a:t>
+              <a:t>6/8/2026</a:t>
             </a:fld>
             <a:endParaRPr lang="en-US" dirty="0"/>
           </a:p>
@@ -3942,7 +3942,7 @@
           <a:p>
             <a:fld id="{4509A250-FF31-4206-8172-F9D3106AACB1}" type="datetimeFigureOut">
               <a:rPr lang="en-US" smtClean="0"/>
-              <a:t>6/7/2026</a:t>
+              <a:t>6/8/2026</a:t>
             </a:fld>
             <a:endParaRPr lang="en-US" dirty="0"/>
           </a:p>
@@ -4127,7 +4127,7 @@
           <a:p>
             <a:fld id="{4509A250-FF31-4206-8172-F9D3106AACB1}" type="datetimeFigureOut">
               <a:rPr lang="en-US" smtClean="0"/>
-              <a:t>6/7/2026</a:t>
+              <a:t>6/8/2026</a:t>
             </a:fld>
             <a:endParaRPr lang="en-US" dirty="0"/>
           </a:p>
@@ -4333,7 +4333,7 @@
           <a:p>
             <a:fld id="{4509A250-FF31-4206-8172-F9D3106AACB1}" type="datetimeFigureOut">
               <a:rPr lang="en-US" smtClean="0"/>
-              <a:t>6/7/2026</a:t>
+              <a:t>6/8/2026</a:t>
             </a:fld>
             <a:endParaRPr lang="en-US" dirty="0"/>
           </a:p>
@@ -4578,7 +4578,7 @@
           <a:p>
             <a:fld id="{9796027F-7875-4030-9381-8BD8C4F21935}" type="datetimeFigureOut">
               <a:rPr lang="en-US" smtClean="0"/>
-              <a:t>6/7/2026</a:t>
+              <a:t>6/8/2026</a:t>
             </a:fld>
             <a:endParaRPr lang="en-US" dirty="0"/>
           </a:p>
@@ -4815,7 +4815,7 @@
           <a:p>
             <a:fld id="{9796027F-7875-4030-9381-8BD8C4F21935}" type="datetimeFigureOut">
               <a:rPr lang="en-US" smtClean="0"/>
-              <a:t>6/7/2026</a:t>
+              <a:t>6/8/2026</a:t>
             </a:fld>
             <a:endParaRPr lang="en-US" dirty="0"/>
           </a:p>
@@ -5282,7 +5282,7 @@
           <a:p>
             <a:fld id="{9796027F-7875-4030-9381-8BD8C4F21935}" type="datetimeFigureOut">
               <a:rPr lang="en-US" smtClean="0"/>
-              <a:t>6/7/2026</a:t>
+              <a:t>6/8/2026</a:t>
             </a:fld>
             <a:endParaRPr lang="en-US" dirty="0"/>
           </a:p>
@@ -5401,7 +5401,7 @@
           <a:p>
             <a:fld id="{4509A250-FF31-4206-8172-F9D3106AACB1}" type="datetimeFigureOut">
               <a:rPr lang="en-US" smtClean="0"/>
-              <a:t>6/7/2026</a:t>
+              <a:t>6/8/2026</a:t>
             </a:fld>
             <a:endParaRPr lang="en-US" dirty="0"/>
           </a:p>
@@ -5497,7 +5497,7 @@
           <a:p>
             <a:fld id="{4509A250-FF31-4206-8172-F9D3106AACB1}" type="datetimeFigureOut">
               <a:rPr lang="en-US" smtClean="0"/>
-              <a:t>6/7/2026</a:t>
+              <a:t>6/8/2026</a:t>
             </a:fld>
             <a:endParaRPr lang="en-US" dirty="0"/>
           </a:p>
@@ -5753,7 +5753,7 @@
           <a:p>
             <a:fld id="{4509A250-FF31-4206-8172-F9D3106AACB1}" type="datetimeFigureOut">
               <a:rPr lang="en-US" smtClean="0"/>
-              <a:t>6/7/2026</a:t>
+              <a:t>6/8/2026</a:t>
             </a:fld>
             <a:endParaRPr lang="en-US" dirty="0"/>
           </a:p>
@@ -6054,7 +6054,7 @@
           <a:p>
             <a:fld id="{4509A250-FF31-4206-8172-F9D3106AACB1}" type="datetimeFigureOut">
               <a:rPr lang="en-US" smtClean="0"/>
-              <a:t>6/7/2026</a:t>
+              <a:t>6/8/2026</a:t>
             </a:fld>
             <a:endParaRPr lang="en-US" dirty="0"/>
           </a:p>
@@ -6289,7 +6289,7 @@
           <a:p>
             <a:fld id="{4AAD347D-5ACD-4C99-B74B-A9C85AD731AF}" type="datetimeFigureOut">
               <a:rPr lang="en-US" smtClean="0"/>
-              <a:t>6/7/2026</a:t>
+              <a:t>6/8/2026</a:t>
             </a:fld>
             <a:endParaRPr lang="en-US" dirty="0"/>
           </a:p>
@@ -8029,7 +8029,7 @@
                 <a:ea typeface="Calibri" pitchFamily="34" charset="-122"/>
                 <a:cs typeface="Calibri" pitchFamily="34" charset="-120"/>
               </a:rPr>
-              <a:t>chegam</a:t>
+              <a:t>cobram</a:t>
             </a:r>
             <a:r>
               <a:rPr lang="en-US" sz="950" dirty="0">
@@ -8040,7 +8040,7 @@
                 <a:ea typeface="Calibri" pitchFamily="34" charset="-122"/>
                 <a:cs typeface="Calibri" pitchFamily="34" charset="-120"/>
               </a:rPr>
-              <a:t> a </a:t>
+              <a:t> </a:t>
             </a:r>
             <a:r>
               <a:rPr lang="en-US" sz="950" dirty="0" err="1">
@@ -8051,7 +8051,7 @@
                 <a:ea typeface="Calibri" pitchFamily="34" charset="-122"/>
                 <a:cs typeface="Calibri" pitchFamily="34" charset="-120"/>
               </a:rPr>
-              <a:t>cobrar</a:t>
+              <a:t>até</a:t>
             </a:r>
             <a:r>
               <a:rPr lang="en-US" sz="950" dirty="0">
@@ -8062,7 +8062,7 @@
                 <a:ea typeface="Calibri" pitchFamily="34" charset="-122"/>
                 <a:cs typeface="Calibri" pitchFamily="34" charset="-120"/>
               </a:rPr>
-              <a:t> até 20% sobre o valor do projeto de </a:t>
+              <a:t> 20% sobre o valor do projeto de </a:t>
             </a:r>
             <a:r>
               <a:rPr lang="en-US" sz="950" dirty="0" err="1">
@@ -9488,7 +9488,73 @@
                 <a:ea typeface="Calibri" pitchFamily="34" charset="-122"/>
                 <a:cs typeface="Calibri" pitchFamily="34" charset="-120"/>
               </a:rPr>
-              <a:t>Os fundos (em USDC) são travados em um Smart Contract de Escrow inalterável. Ninguém — nem os criadores da plataforma — pode movimentar esse dinheiro.</a:t>
+              <a:t>Os fundos (em USDC) são travados em um Smart Contract de Escrow inalterável. </a:t>
+            </a:r>
+            <a:r>
+              <a:rPr lang="en-US" sz="950" dirty="0" err="1">
+                <a:solidFill>
+                  <a:srgbClr val="8AAFB0"/>
+                </a:solidFill>
+                <a:latin typeface="Calibri" pitchFamily="34" charset="0"/>
+                <a:ea typeface="Calibri" pitchFamily="34" charset="-122"/>
+                <a:cs typeface="Calibri" pitchFamily="34" charset="-120"/>
+              </a:rPr>
+              <a:t>Ninguém</a:t>
+            </a:r>
+            <a:r>
+              <a:rPr lang="en-US" sz="950" dirty="0">
+                <a:solidFill>
+                  <a:srgbClr val="8AAFB0"/>
+                </a:solidFill>
+                <a:latin typeface="Calibri" pitchFamily="34" charset="0"/>
+                <a:ea typeface="Calibri" pitchFamily="34" charset="-122"/>
+                <a:cs typeface="Calibri" pitchFamily="34" charset="-120"/>
+              </a:rPr>
+              <a:t> </a:t>
+            </a:r>
+            <a:r>
+              <a:rPr lang="en-US" sz="950" dirty="0" err="1">
+                <a:solidFill>
+                  <a:srgbClr val="8AAFB0"/>
+                </a:solidFill>
+                <a:latin typeface="Calibri" pitchFamily="34" charset="0"/>
+                <a:ea typeface="Calibri" pitchFamily="34" charset="-122"/>
+                <a:cs typeface="Calibri" pitchFamily="34" charset="-120"/>
+              </a:rPr>
+              <a:t>nem</a:t>
+            </a:r>
+            <a:r>
+              <a:rPr lang="en-US" sz="950" dirty="0">
+                <a:solidFill>
+                  <a:srgbClr val="8AAFB0"/>
+                </a:solidFill>
+                <a:latin typeface="Calibri" pitchFamily="34" charset="0"/>
+                <a:ea typeface="Calibri" pitchFamily="34" charset="-122"/>
+                <a:cs typeface="Calibri" pitchFamily="34" charset="-120"/>
+              </a:rPr>
+              <a:t> os criadores da Plataforma, </a:t>
+            </a:r>
+            <a:r>
+              <a:rPr lang="en-US" sz="950" dirty="0" err="1">
+                <a:solidFill>
+                  <a:srgbClr val="8AAFB0"/>
+                </a:solidFill>
+                <a:latin typeface="Calibri" pitchFamily="34" charset="0"/>
+                <a:ea typeface="Calibri" pitchFamily="34" charset="-122"/>
+                <a:cs typeface="Calibri" pitchFamily="34" charset="-120"/>
+              </a:rPr>
+              <a:t>pode</a:t>
+            </a:r>
+            <a:r>
+              <a:rPr lang="en-US" sz="950" dirty="0">
+                <a:solidFill>
+                  <a:srgbClr val="8AAFB0"/>
+                </a:solidFill>
+                <a:latin typeface="Calibri" pitchFamily="34" charset="0"/>
+                <a:ea typeface="Calibri" pitchFamily="34" charset="-122"/>
+                <a:cs typeface="Calibri" pitchFamily="34" charset="-120"/>
+              </a:rPr>
+              <a:t> movimentar esse dinheiro.</a:t>
             </a:r>
             <a:endParaRPr lang="en-US" sz="950" dirty="0"/>
           </a:p>
@@ -13198,7 +13264,23 @@
                   <a:srgbClr val="8B949E"/>
                 </a:solidFill>
               </a:rPr>
-              <a:t>depositar</a:t>
+              <a:t>assinar</a:t>
+            </a:r>
+            <a:r>
+              <a:rPr lang="en-US" sz="850" dirty="0">
+                <a:solidFill>
+                  <a:srgbClr val="8B949E"/>
+                </a:solidFill>
+              </a:rPr>
+              <a:t> o </a:t>
+            </a:r>
+            <a:r>
+              <a:rPr lang="en-US" sz="850" dirty="0" err="1">
+                <a:solidFill>
+                  <a:srgbClr val="8B949E"/>
+                </a:solidFill>
+              </a:rPr>
+              <a:t>contrato</a:t>
             </a:r>
             <a:r>
               <a:rPr lang="en-US" sz="850" dirty="0">
@@ -14791,12 +14873,12 @@
               <a:buNone/>
             </a:pPr>
             <a:r>
-              <a:rPr lang="en-US" sz="700" dirty="0">
+              <a:rPr lang="en-US" sz="700" dirty="0" err="1">
                 <a:solidFill>
                   <a:srgbClr val="00C9A7"/>
                 </a:solidFill>
               </a:rPr>
-              <a:t>Factory</a:t>
+              <a:t>Factory.sol</a:t>
             </a:r>
             <a:endParaRPr lang="en-US" sz="700" dirty="0"/>
           </a:p>
@@ -14827,12 +14909,24 @@
               <a:buNone/>
             </a:pPr>
             <a:r>
-              <a:rPr lang="en-US" sz="750" dirty="0">
-                <a:solidFill>
-                  <a:srgbClr val="8B949E"/>
-                </a:solidFill>
-              </a:rPr>
-              <a:t>enderecoEscrow (indexed), contratante (indexed), prestador</a:t>
+              <a:rPr lang="pt-BR" sz="750" dirty="0"/>
+              <a:t>Emissão global após </a:t>
+            </a:r>
+            <a:r>
+              <a:rPr lang="pt-BR" sz="750" dirty="0" err="1"/>
+              <a:t>deploy</a:t>
+            </a:r>
+            <a:r>
+              <a:rPr lang="pt-BR" sz="750" dirty="0"/>
+              <a:t> de nova instância via </a:t>
+            </a:r>
+            <a:r>
+              <a:rPr lang="pt-BR" sz="750" dirty="0" err="1"/>
+              <a:t>factory</a:t>
+            </a:r>
+            <a:r>
+              <a:rPr lang="pt-BR" sz="750" dirty="0"/>
+              <a:t>.</a:t>
             </a:r>
             <a:endParaRPr lang="en-US" sz="750" dirty="0"/>
           </a:p>
@@ -14913,7 +15007,7 @@
               <a:buNone/>
             </a:pPr>
             <a:r>
-              <a:rPr lang="en-US" sz="850" b="1" dirty="0">
+              <a:rPr lang="en-US" sz="850" b="1" dirty="0" err="1">
                 <a:solidFill>
                   <a:srgbClr val="FFFFFF"/>
                 </a:solidFill>
@@ -14921,7 +15015,7 @@
                 <a:ea typeface="Consolas" pitchFamily="34" charset="-122"/>
                 <a:cs typeface="Consolas" pitchFamily="34" charset="-120"/>
               </a:rPr>
-              <a:t>ServicoDepositado</a:t>
+              <a:t>ContratoAceito</a:t>
             </a:r>
             <a:endParaRPr lang="en-US" sz="850" dirty="0"/>
           </a:p>
@@ -14979,12 +15073,12 @@
               <a:buNone/>
             </a:pPr>
             <a:r>
-              <a:rPr lang="en-US" sz="700" dirty="0">
+              <a:rPr lang="en-US" sz="700" dirty="0" err="1">
                 <a:solidFill>
                   <a:srgbClr val="00C9A7"/>
                 </a:solidFill>
               </a:rPr>
-              <a:t>Escrow</a:t>
+              <a:t>Escrow.sol</a:t>
             </a:r>
             <a:endParaRPr lang="en-US" sz="700" dirty="0"/>
           </a:p>
@@ -15015,12 +15109,12 @@
               <a:buNone/>
             </a:pPr>
             <a:r>
-              <a:rPr lang="en-US" sz="750" dirty="0">
+              <a:rPr lang="pt-BR" sz="750" dirty="0">
                 <a:solidFill>
                   <a:srgbClr val="8B949E"/>
                 </a:solidFill>
               </a:rPr>
-              <a:t>valor — sinaliza confirmação do depósito ao frontend</a:t>
+              <a:t>Confirmação de aceite e participação do prestador de serviço.</a:t>
             </a:r>
             <a:endParaRPr lang="en-US" sz="750" dirty="0"/>
           </a:p>
@@ -15101,7 +15195,7 @@
               <a:buNone/>
             </a:pPr>
             <a:r>
-              <a:rPr lang="en-US" sz="850" b="1" dirty="0">
+              <a:rPr lang="en-US" sz="850" b="1" dirty="0" err="1">
                 <a:solidFill>
                   <a:srgbClr val="FFFFFF"/>
                 </a:solidFill>
@@ -15109,7 +15203,7 @@
                 <a:ea typeface="Consolas" pitchFamily="34" charset="-122"/>
                 <a:cs typeface="Consolas" pitchFamily="34" charset="-120"/>
               </a:rPr>
-              <a:t>ServicoEntregue</a:t>
+              <a:t>ServicoDepositado</a:t>
             </a:r>
             <a:endParaRPr lang="en-US" sz="850" dirty="0"/>
           </a:p>
@@ -15167,12 +15261,12 @@
               <a:buNone/>
             </a:pPr>
             <a:r>
-              <a:rPr lang="en-US" sz="700" dirty="0">
+              <a:rPr lang="en-US" sz="700" dirty="0" err="1">
                 <a:solidFill>
                   <a:srgbClr val="00C9A7"/>
                 </a:solidFill>
               </a:rPr>
-              <a:t>Escrow</a:t>
+              <a:t>Escrow.sol</a:t>
             </a:r>
             <a:endParaRPr lang="en-US" sz="700" dirty="0"/>
           </a:p>
@@ -15203,12 +15297,12 @@
               <a:buNone/>
             </a:pPr>
             <a:r>
-              <a:rPr lang="en-US" sz="750" dirty="0">
+              <a:rPr lang="pt-BR" sz="750" dirty="0">
                 <a:solidFill>
                   <a:srgbClr val="8B949E"/>
                 </a:solidFill>
               </a:rPr>
-              <a:t>timestamp — inicia contador de 3 dias para auto-release</a:t>
+              <a:t>Tokens ERC-20 bloqueados com sucesso no contrato inteligente.</a:t>
             </a:r>
             <a:endParaRPr lang="en-US" sz="750" dirty="0"/>
           </a:p>
@@ -15272,7 +15366,7 @@
         </p:nvSpPr>
         <p:spPr>
           <a:xfrm>
-            <a:off x="594360" y="2532888"/>
+            <a:off x="594360" y="2578608"/>
             <a:ext cx="1371600" cy="274320"/>
           </a:xfrm>
           <a:prstGeom prst="rect">
@@ -15289,7 +15383,7 @@
               <a:buNone/>
             </a:pPr>
             <a:r>
-              <a:rPr lang="en-US" sz="850" b="1" dirty="0">
+              <a:rPr lang="en-US" sz="850" b="1" dirty="0" err="1">
                 <a:solidFill>
                   <a:srgbClr val="FFFFFF"/>
                 </a:solidFill>
@@ -15297,8 +15391,21 @@
                 <a:ea typeface="Consolas" pitchFamily="34" charset="-122"/>
                 <a:cs typeface="Consolas" pitchFamily="34" charset="-120"/>
               </a:rPr>
-              <a:t>PagamentoRealizado</a:t>
-            </a:r>
+              <a:t>ServicoEntregue</a:t>
+            </a:r>
+            <a:endParaRPr lang="en-US" sz="850" b="1" dirty="0">
+              <a:solidFill>
+                <a:srgbClr val="FFFFFF"/>
+              </a:solidFill>
+              <a:latin typeface="Consolas" pitchFamily="34" charset="0"/>
+              <a:ea typeface="Consolas" pitchFamily="34" charset="-122"/>
+              <a:cs typeface="Consolas" pitchFamily="34" charset="-120"/>
+            </a:endParaRPr>
+          </a:p>
+          <a:p>
+            <a:pPr marL="0" indent="0">
+              <a:buNone/>
+            </a:pPr>
             <a:endParaRPr lang="en-US" sz="850" dirty="0"/>
           </a:p>
         </p:txBody>
@@ -15355,12 +15462,12 @@
               <a:buNone/>
             </a:pPr>
             <a:r>
-              <a:rPr lang="en-US" sz="700" dirty="0">
+              <a:rPr lang="en-US" sz="700" dirty="0" err="1">
                 <a:solidFill>
                   <a:srgbClr val="00C9A7"/>
                 </a:solidFill>
               </a:rPr>
-              <a:t>Escrow</a:t>
+              <a:t>Escrow.sol</a:t>
             </a:r>
             <a:endParaRPr lang="en-US" sz="700" dirty="0"/>
           </a:p>
@@ -15374,7 +15481,7 @@
         </p:nvSpPr>
         <p:spPr>
           <a:xfrm>
-            <a:off x="2542032" y="2532888"/>
+            <a:off x="2542032" y="2478024"/>
             <a:ext cx="2743200" cy="274320"/>
           </a:xfrm>
           <a:prstGeom prst="rect">
@@ -15390,13 +15497,23 @@
             <a:pPr marL="0" indent="0">
               <a:buNone/>
             </a:pPr>
-            <a:r>
-              <a:rPr lang="en-US" sz="750" dirty="0">
-                <a:solidFill>
-                  <a:srgbClr val="8B949E"/>
-                </a:solidFill>
-              </a:rPr>
-              <a:t>prestador (indexed), valor — emitido em ambas as funções de pago</a:t>
+            <a:endParaRPr lang="pt-BR" sz="750" dirty="0"/>
+          </a:p>
+          <a:p>
+            <a:pPr marL="0" indent="0">
+              <a:buNone/>
+            </a:pPr>
+            <a:r>
+              <a:rPr lang="pt-BR" sz="750" dirty="0"/>
+              <a:t>Sinalização de conclusão; inicia contagem de </a:t>
+            </a:r>
+            <a:r>
+              <a:rPr lang="pt-BR" sz="750" dirty="0" err="1"/>
+              <a:t>auto-liberação</a:t>
+            </a:r>
+            <a:r>
+              <a:rPr lang="pt-BR" sz="750" dirty="0"/>
+              <a:t>.</a:t>
             </a:r>
             <a:endParaRPr lang="en-US" sz="750" dirty="0"/>
           </a:p>
@@ -15543,12 +15660,12 @@
               <a:buNone/>
             </a:pPr>
             <a:r>
-              <a:rPr lang="en-US" sz="700" dirty="0">
+              <a:rPr lang="en-US" sz="700" dirty="0" err="1">
                 <a:solidFill>
                   <a:srgbClr val="00C9A7"/>
                 </a:solidFill>
               </a:rPr>
-              <a:t>Escrow</a:t>
+              <a:t>Escrow.sol</a:t>
             </a:r>
             <a:endParaRPr lang="en-US" sz="700" dirty="0"/>
           </a:p>
@@ -15579,14 +15696,13 @@
               <a:buNone/>
             </a:pPr>
             <a:r>
-              <a:rPr lang="en-US" sz="750" dirty="0">
+              <a:rPr lang="pt-BR" sz="750" dirty="0">
                 <a:solidFill>
                   <a:srgbClr val="8B949E"/>
                 </a:solidFill>
               </a:rPr>
-              <a:t>quemIniciou (indexed) — congelamento do contrato</a:t>
-            </a:r>
-            <a:endParaRPr lang="en-US" sz="750" dirty="0"/>
+              <a:t>Bloqueio total de fundos aguardando resolução via árbitro neutro.</a:t>
+            </a:r>
           </a:p>
         </p:txBody>
       </p:sp>
@@ -15665,7 +15781,7 @@
               <a:buNone/>
             </a:pPr>
             <a:r>
-              <a:rPr lang="en-US" sz="850" b="1" dirty="0">
+              <a:rPr lang="en-US" sz="850" b="1" dirty="0" err="1">
                 <a:solidFill>
                   <a:srgbClr val="FFFFFF"/>
                 </a:solidFill>
@@ -15673,7 +15789,7 @@
                 <a:ea typeface="Consolas" pitchFamily="34" charset="-122"/>
                 <a:cs typeface="Consolas" pitchFamily="34" charset="-120"/>
               </a:rPr>
-              <a:t>ReembolsoRealizado</a:t>
+              <a:t>PagamentoRealizado</a:t>
             </a:r>
             <a:endParaRPr lang="en-US" sz="850" dirty="0"/>
           </a:p>
@@ -15731,12 +15847,12 @@
               <a:buNone/>
             </a:pPr>
             <a:r>
-              <a:rPr lang="en-US" sz="700" dirty="0">
+              <a:rPr lang="en-US" sz="700" dirty="0" err="1">
                 <a:solidFill>
                   <a:srgbClr val="00C9A7"/>
                 </a:solidFill>
               </a:rPr>
-              <a:t>Escrow</a:t>
+              <a:t>Escrow.sol</a:t>
             </a:r>
             <a:endParaRPr lang="en-US" sz="700" dirty="0"/>
           </a:p>
@@ -15767,12 +15883,12 @@
               <a:buNone/>
             </a:pPr>
             <a:r>
-              <a:rPr lang="en-US" sz="750" dirty="0">
+              <a:rPr lang="pt-BR" sz="750" dirty="0">
                 <a:solidFill>
                   <a:srgbClr val="8B949E"/>
                 </a:solidFill>
               </a:rPr>
-              <a:t>contratante (indexed) — após 30 dias sem entrega</a:t>
+              <a:t>Liberação dos tokens e encerramento do ciclo de vida contratual.</a:t>
             </a:r>
             <a:endParaRPr lang="en-US" sz="750" dirty="0"/>
           </a:p>
@@ -15787,7 +15903,7 @@
         <p:spPr>
           <a:xfrm>
             <a:off x="365760" y="3657600"/>
-            <a:ext cx="5120640" cy="1234440"/>
+            <a:ext cx="5212080" cy="1234440"/>
           </a:xfrm>
           <a:prstGeom prst="rect">
             <a:avLst/>
@@ -15960,6 +16076,13 @@
             <a:prstDash val="solid"/>
           </a:ln>
         </p:spPr>
+        <p:txBody>
+          <a:bodyPr/>
+          <a:lstStyle/>
+          <a:p>
+            <a:endParaRPr lang="pt-BR" dirty="0"/>
+          </a:p>
+        </p:txBody>
       </p:sp>
       <p:sp>
         <p:nvSpPr>
@@ -16027,7 +16150,39 @@
                   <a:srgbClr val="8B949E"/>
                 </a:solidFill>
               </a:rPr>
-              <a:t>Sempre msg.sender para verificar autorização — tx.origin é vulnerável a phishing</a:t>
+              <a:t>Sempre msg.sender para </a:t>
+            </a:r>
+            <a:r>
+              <a:rPr lang="en-US" sz="700" dirty="0" err="1">
+                <a:solidFill>
+                  <a:srgbClr val="8B949E"/>
+                </a:solidFill>
+              </a:rPr>
+              <a:t>verificar</a:t>
+            </a:r>
+            <a:r>
+              <a:rPr lang="en-US" sz="700" dirty="0">
+                <a:solidFill>
+                  <a:srgbClr val="8B949E"/>
+                </a:solidFill>
+              </a:rPr>
+              <a:t> </a:t>
+            </a:r>
+            <a:r>
+              <a:rPr lang="en-US" sz="700" dirty="0" err="1">
+                <a:solidFill>
+                  <a:srgbClr val="8B949E"/>
+                </a:solidFill>
+              </a:rPr>
+              <a:t>autorização</a:t>
+            </a:r>
+            <a:r>
+              <a:rPr lang="en-US" sz="700" dirty="0">
+                <a:solidFill>
+                  <a:srgbClr val="8B949E"/>
+                </a:solidFill>
+              </a:rPr>
+              <a:t>, pois tx.origin é vulnerável a phishing</a:t>
             </a:r>
             <a:endParaRPr lang="en-US" sz="700" dirty="0"/>
           </a:p>
@@ -16124,7 +16279,23 @@
                   <a:srgbClr val="8B949E"/>
                 </a:solidFill>
               </a:rPr>
-              <a:t>Funções de pagamento não são payable — contrato já possui o saldo do token</a:t>
+              <a:t>Funções de pagamento não </a:t>
+            </a:r>
+            <a:r>
+              <a:rPr lang="en-US" sz="700" dirty="0" err="1">
+                <a:solidFill>
+                  <a:srgbClr val="8B949E"/>
+                </a:solidFill>
+              </a:rPr>
+              <a:t>são</a:t>
+            </a:r>
+            <a:r>
+              <a:rPr lang="en-US" sz="700" dirty="0">
+                <a:solidFill>
+                  <a:srgbClr val="8B949E"/>
+                </a:solidFill>
+              </a:rPr>
+              <a:t> payable, contrato já possui o saldo do token</a:t>
             </a:r>
             <a:endParaRPr lang="en-US" sz="700" dirty="0"/>
           </a:p>
@@ -16221,7 +16392,79 @@
                   <a:srgbClr val="8B949E"/>
                 </a:solidFill>
               </a:rPr>
-              <a:t>Cada projeto tem seu próprio Escrow.sol — falha não se propaga</a:t>
+              <a:t>Cada projeto tem seu próprio </a:t>
+            </a:r>
+            <a:r>
+              <a:rPr lang="en-US" sz="700" dirty="0" err="1">
+                <a:solidFill>
+                  <a:srgbClr val="8B949E"/>
+                </a:solidFill>
+              </a:rPr>
+              <a:t>Escrow.sol</a:t>
+            </a:r>
+            <a:r>
+              <a:rPr lang="en-US" sz="700" dirty="0">
+                <a:solidFill>
+                  <a:srgbClr val="8B949E"/>
+                </a:solidFill>
+              </a:rPr>
+              <a:t>, se um </a:t>
+            </a:r>
+            <a:r>
+              <a:rPr lang="en-US" sz="700" dirty="0" err="1">
+                <a:solidFill>
+                  <a:srgbClr val="8B949E"/>
+                </a:solidFill>
+              </a:rPr>
+              <a:t>falha</a:t>
+            </a:r>
+            <a:r>
+              <a:rPr lang="en-US" sz="700" dirty="0">
+                <a:solidFill>
+                  <a:srgbClr val="8B949E"/>
+                </a:solidFill>
+              </a:rPr>
+              <a:t> não se </a:t>
+            </a:r>
+            <a:r>
+              <a:rPr lang="en-US" sz="700" dirty="0" err="1">
+                <a:solidFill>
+                  <a:srgbClr val="8B949E"/>
+                </a:solidFill>
+              </a:rPr>
+              <a:t>propaga</a:t>
+            </a:r>
+            <a:r>
+              <a:rPr lang="en-US" sz="700" dirty="0">
+                <a:solidFill>
+                  <a:srgbClr val="8B949E"/>
+                </a:solidFill>
+              </a:rPr>
+              <a:t> </a:t>
+            </a:r>
+            <a:r>
+              <a:rPr lang="en-US" sz="700" dirty="0" err="1">
+                <a:solidFill>
+                  <a:srgbClr val="8B949E"/>
+                </a:solidFill>
+              </a:rPr>
+              <a:t>aos</a:t>
+            </a:r>
+            <a:r>
+              <a:rPr lang="en-US" sz="700" dirty="0">
+                <a:solidFill>
+                  <a:srgbClr val="8B949E"/>
+                </a:solidFill>
+              </a:rPr>
+              <a:t> outros </a:t>
+            </a:r>
+            <a:r>
+              <a:rPr lang="en-US" sz="700" dirty="0" err="1">
+                <a:solidFill>
+                  <a:srgbClr val="8B949E"/>
+                </a:solidFill>
+              </a:rPr>
+              <a:t>contratos</a:t>
             </a:r>
             <a:endParaRPr lang="en-US" sz="700" dirty="0"/>
           </a:p>
@@ -16340,14 +16583,14 @@
       </p:sp>
       <p:sp>
         <p:nvSpPr>
-          <p:cNvPr id="61" name="Text 59"/>
-          <p:cNvSpPr/>
-          <p:nvPr/>
-        </p:nvSpPr>
-        <p:spPr>
-          <a:xfrm>
-            <a:off x="5897880" y="1709928"/>
-            <a:ext cx="2468880" cy="182880"/>
+          <p:cNvPr id="62" name="Text 60"/>
+          <p:cNvSpPr/>
+          <p:nvPr/>
+        </p:nvSpPr>
+        <p:spPr>
+          <a:xfrm>
+            <a:off x="5897880" y="1746504"/>
+            <a:ext cx="2468880" cy="292608"/>
           </a:xfrm>
           <a:prstGeom prst="rect">
             <a:avLst/>
@@ -16359,57 +16602,86 @@
           <a:bodyPr wrap="square" lIns="0" tIns="0" rIns="0" bIns="0" rtlCol="0" anchor="ctr"/>
           <a:lstStyle/>
           <a:p>
-            <a:pPr marL="0" indent="0">
-              <a:buNone/>
-            </a:pPr>
-            <a:r>
-              <a:rPr lang="en-US" sz="900" b="1" dirty="0">
+            <a:pPr algn="l">
+              <a:buFont typeface="Arial" panose="020B0604020202020204" pitchFamily="34" charset="0"/>
+              <a:buChar char="•"/>
+            </a:pPr>
+            <a:r>
+              <a:rPr lang="pt-BR" sz="800" b="1" i="0" dirty="0" err="1">
+                <a:solidFill>
+                  <a:srgbClr val="00F2FF"/>
+                </a:solidFill>
+                <a:effectLst/>
+                <a:latin typeface="Poppins" panose="00000500000000000000" pitchFamily="2" charset="0"/>
+              </a:rPr>
+              <a:t>Approve</a:t>
+            </a:r>
+            <a:r>
+              <a:rPr lang="pt-BR" sz="800" b="1" i="0" dirty="0">
+                <a:solidFill>
+                  <a:srgbClr val="00F2FF"/>
+                </a:solidFill>
+                <a:effectLst/>
+                <a:latin typeface="Poppins" panose="00000500000000000000" pitchFamily="2" charset="0"/>
+              </a:rPr>
+              <a:t> + Execute</a:t>
+            </a:r>
+          </a:p>
+          <a:p>
+            <a:pPr algn="l">
+              <a:buFont typeface="Arial" panose="020B0604020202020204" pitchFamily="34" charset="0"/>
+              <a:buChar char="•"/>
+            </a:pPr>
+            <a:r>
+              <a:rPr lang="pt-BR" sz="800" b="0" i="0" dirty="0">
                 <a:solidFill>
                   <a:srgbClr val="FFFFFF"/>
                 </a:solidFill>
-                <a:latin typeface="Consolas" pitchFamily="34" charset="0"/>
-                <a:ea typeface="Consolas" pitchFamily="34" charset="-122"/>
-                <a:cs typeface="Consolas" pitchFamily="34" charset="-120"/>
-              </a:rPr>
-              <a:t>decodeEventLog (viem)</a:t>
-            </a:r>
-            <a:endParaRPr lang="en-US" sz="900" dirty="0"/>
-          </a:p>
-        </p:txBody>
-      </p:sp>
-      <p:sp>
-        <p:nvSpPr>
-          <p:cNvPr id="62" name="Text 60"/>
-          <p:cNvSpPr/>
-          <p:nvPr/>
-        </p:nvSpPr>
-        <p:spPr>
-          <a:xfrm>
-            <a:off x="5897880" y="1892808"/>
-            <a:ext cx="2468880" cy="292608"/>
-          </a:xfrm>
-          <a:prstGeom prst="rect">
-            <a:avLst/>
-          </a:prstGeom>
-          <a:noFill/>
-          <a:ln/>
-        </p:spPr>
-        <p:txBody>
-          <a:bodyPr wrap="square" lIns="0" tIns="0" rIns="0" bIns="0" rtlCol="0" anchor="ctr"/>
-          <a:lstStyle/>
-          <a:p>
-            <a:pPr marL="0" indent="0">
-              <a:buNone/>
-            </a:pPr>
-            <a:r>
-              <a:rPr lang="en-US" sz="750" dirty="0">
-                <a:solidFill>
-                  <a:srgbClr val="8B949E"/>
-                </a:solidFill>
-              </a:rPr>
-              <a:t>Decodifica logs binários do evento EscrowCriado para extrair o endereço do contrato filho e vincular ao banco de dados</a:t>
-            </a:r>
-            <a:endParaRPr lang="en-US" sz="750" dirty="0"/>
+                <a:effectLst/>
+                <a:latin typeface="Poppins" panose="00000500000000000000" pitchFamily="2" charset="0"/>
+              </a:rPr>
+              <a:t>O fluxo exige </a:t>
+            </a:r>
+            <a:r>
+              <a:rPr lang="pt-BR" sz="800" b="0" i="0" dirty="0" err="1">
+                <a:solidFill>
+                  <a:srgbClr val="FFFFFF"/>
+                </a:solidFill>
+                <a:effectLst/>
+                <a:latin typeface="Poppins" panose="00000500000000000000" pitchFamily="2" charset="0"/>
+              </a:rPr>
+              <a:t>approve</a:t>
+            </a:r>
+            <a:r>
+              <a:rPr lang="pt-BR" sz="800" b="0" i="0" dirty="0">
+                <a:solidFill>
+                  <a:srgbClr val="FFFFFF"/>
+                </a:solidFill>
+                <a:effectLst/>
+                <a:latin typeface="Poppins" panose="00000500000000000000" pitchFamily="2" charset="0"/>
+              </a:rPr>
+              <a:t>() no token antes do </a:t>
+            </a:r>
+            <a:r>
+              <a:rPr lang="pt-BR" sz="800" b="0" i="0" dirty="0" err="1">
+                <a:solidFill>
+                  <a:srgbClr val="FFFFFF"/>
+                </a:solidFill>
+                <a:effectLst/>
+                <a:latin typeface="Poppins" panose="00000500000000000000" pitchFamily="2" charset="0"/>
+              </a:rPr>
+              <a:t>criaEscrow</a:t>
+            </a:r>
+            <a:r>
+              <a:rPr lang="pt-BR" sz="800" b="0" i="0" dirty="0">
+                <a:solidFill>
+                  <a:srgbClr val="FFFFFF"/>
+                </a:solidFill>
+                <a:effectLst/>
+                <a:latin typeface="Poppins" panose="00000500000000000000" pitchFamily="2" charset="0"/>
+              </a:rPr>
+              <a:t>() para garantir a custódia imediata.</a:t>
+            </a:r>
           </a:p>
         </p:txBody>
       </p:sp>
@@ -16422,7 +16694,7 @@
         <p:spPr>
           <a:xfrm>
             <a:off x="5806440" y="2286000"/>
-            <a:ext cx="2651760" cy="566928"/>
+            <a:ext cx="2651760" cy="466344"/>
           </a:xfrm>
           <a:prstGeom prst="rect">
             <a:avLst/>
@@ -16446,8 +16718,8 @@
         </p:nvSpPr>
         <p:spPr>
           <a:xfrm>
-            <a:off x="5806440" y="2286000"/>
-            <a:ext cx="36576" cy="566928"/>
+            <a:off x="5806439" y="2286000"/>
+            <a:ext cx="45719" cy="457200"/>
           </a:xfrm>
           <a:prstGeom prst="rect">
             <a:avLst/>
@@ -16465,14 +16737,14 @@
       </p:sp>
       <p:sp>
         <p:nvSpPr>
-          <p:cNvPr id="65" name="Text 63"/>
-          <p:cNvSpPr/>
-          <p:nvPr/>
-        </p:nvSpPr>
-        <p:spPr>
-          <a:xfrm>
-            <a:off x="5897880" y="2331720"/>
-            <a:ext cx="2468880" cy="182880"/>
+          <p:cNvPr id="66" name="Text 64"/>
+          <p:cNvSpPr/>
+          <p:nvPr/>
+        </p:nvSpPr>
+        <p:spPr>
+          <a:xfrm>
+            <a:off x="5897880" y="2368296"/>
+            <a:ext cx="2468880" cy="292608"/>
           </a:xfrm>
           <a:prstGeom prst="rect">
             <a:avLst/>
@@ -16484,57 +16756,66 @@
           <a:bodyPr wrap="square" lIns="0" tIns="0" rIns="0" bIns="0" rtlCol="0" anchor="ctr"/>
           <a:lstStyle/>
           <a:p>
-            <a:pPr marL="0" indent="0">
-              <a:buNone/>
-            </a:pPr>
-            <a:r>
-              <a:rPr lang="en-US" sz="900" b="1" dirty="0">
+            <a:pPr algn="l">
+              <a:buFont typeface="Arial" panose="020B0604020202020204" pitchFamily="34" charset="0"/>
+              <a:buChar char="•"/>
+            </a:pPr>
+            <a:r>
+              <a:rPr lang="pt-BR" sz="800" b="1" i="0" dirty="0" err="1">
+                <a:solidFill>
+                  <a:srgbClr val="00F2FF"/>
+                </a:solidFill>
+                <a:effectLst/>
+                <a:latin typeface="Poppins" panose="00000500000000000000" pitchFamily="2" charset="0"/>
+              </a:rPr>
+              <a:t>Polling</a:t>
+            </a:r>
+            <a:r>
+              <a:rPr lang="pt-BR" sz="800" b="1" i="0" dirty="0">
+                <a:solidFill>
+                  <a:srgbClr val="00F2FF"/>
+                </a:solidFill>
+                <a:effectLst/>
+                <a:latin typeface="Poppins" panose="00000500000000000000" pitchFamily="2" charset="0"/>
+              </a:rPr>
+              <a:t> de Estado (</a:t>
+            </a:r>
+            <a:r>
+              <a:rPr lang="pt-BR" sz="800" b="1" i="0" dirty="0" err="1">
+                <a:solidFill>
+                  <a:srgbClr val="00F2FF"/>
+                </a:solidFill>
+                <a:effectLst/>
+                <a:latin typeface="Poppins" panose="00000500000000000000" pitchFamily="2" charset="0"/>
+              </a:rPr>
+              <a:t>Enum</a:t>
+            </a:r>
+            <a:r>
+              <a:rPr lang="pt-BR" sz="800" b="1" i="0" dirty="0">
+                <a:solidFill>
+                  <a:srgbClr val="00F2FF"/>
+                </a:solidFill>
+                <a:effectLst/>
+                <a:latin typeface="Poppins" panose="00000500000000000000" pitchFamily="2" charset="0"/>
+              </a:rPr>
+              <a:t>)</a:t>
+            </a:r>
+          </a:p>
+          <a:p>
+            <a:pPr algn="l">
+              <a:buFont typeface="Arial" panose="020B0604020202020204" pitchFamily="34" charset="0"/>
+              <a:buChar char="•"/>
+            </a:pPr>
+            <a:r>
+              <a:rPr lang="pt-BR" sz="800" b="0" i="0" dirty="0">
                 <a:solidFill>
                   <a:srgbClr val="FFFFFF"/>
                 </a:solidFill>
-                <a:latin typeface="Consolas" pitchFamily="34" charset="0"/>
-                <a:ea typeface="Consolas" pitchFamily="34" charset="-122"/>
-                <a:cs typeface="Consolas" pitchFamily="34" charset="-120"/>
-              </a:rPr>
-              <a:t>Gas Limit Override</a:t>
-            </a:r>
-            <a:endParaRPr lang="en-US" sz="900" dirty="0"/>
-          </a:p>
-        </p:txBody>
-      </p:sp>
-      <p:sp>
-        <p:nvSpPr>
-          <p:cNvPr id="66" name="Text 64"/>
-          <p:cNvSpPr/>
-          <p:nvPr/>
-        </p:nvSpPr>
-        <p:spPr>
-          <a:xfrm>
-            <a:off x="5897880" y="2514600"/>
-            <a:ext cx="2468880" cy="292608"/>
-          </a:xfrm>
-          <a:prstGeom prst="rect">
-            <a:avLst/>
-          </a:prstGeom>
-          <a:noFill/>
-          <a:ln/>
-        </p:spPr>
-        <p:txBody>
-          <a:bodyPr wrap="square" lIns="0" tIns="0" rIns="0" bIns="0" rtlCol="0" anchor="ctr"/>
-          <a:lstStyle/>
-          <a:p>
-            <a:pPr marL="0" indent="0">
-              <a:buNone/>
-            </a:pPr>
-            <a:r>
-              <a:rPr lang="en-US" sz="750" dirty="0">
-                <a:solidFill>
-                  <a:srgbClr val="8B949E"/>
-                </a:solidFill>
-              </a:rPr>
-              <a:t>Injeta limites manuais de gas nas chamadas de escrita para contornar estimativas instáveis de nós RPC em testnets</a:t>
-            </a:r>
-            <a:endParaRPr lang="en-US" sz="750" dirty="0"/>
+                <a:effectLst/>
+                <a:latin typeface="Poppins" panose="00000500000000000000" pitchFamily="2" charset="0"/>
+              </a:rPr>
+              <a:t>Mapeamento dinâmico do estado (0-5) para alternância de botões e visão da UI.</a:t>
+            </a:r>
           </a:p>
         </p:txBody>
       </p:sp>
@@ -16547,7 +16828,7 @@
         <p:spPr>
           <a:xfrm>
             <a:off x="5806440" y="2907792"/>
-            <a:ext cx="2651760" cy="566928"/>
+            <a:ext cx="2651760" cy="502920"/>
           </a:xfrm>
           <a:prstGeom prst="rect">
             <a:avLst/>
@@ -16571,8 +16852,8 @@
         </p:nvSpPr>
         <p:spPr>
           <a:xfrm>
-            <a:off x="5806440" y="2907792"/>
-            <a:ext cx="36576" cy="566928"/>
+            <a:off x="5806439" y="2907792"/>
+            <a:ext cx="45719" cy="502920"/>
           </a:xfrm>
           <a:prstGeom prst="rect">
             <a:avLst/>
@@ -16590,14 +16871,14 @@
       </p:sp>
       <p:sp>
         <p:nvSpPr>
-          <p:cNvPr id="69" name="Text 67"/>
-          <p:cNvSpPr/>
-          <p:nvPr/>
-        </p:nvSpPr>
-        <p:spPr>
-          <a:xfrm>
-            <a:off x="5897880" y="2953512"/>
-            <a:ext cx="2468880" cy="182880"/>
+          <p:cNvPr id="70" name="Text 68"/>
+          <p:cNvSpPr/>
+          <p:nvPr/>
+        </p:nvSpPr>
+        <p:spPr>
+          <a:xfrm>
+            <a:off x="5897880" y="3067812"/>
+            <a:ext cx="2468880" cy="292608"/>
           </a:xfrm>
           <a:prstGeom prst="rect">
             <a:avLst/>
@@ -16609,56 +16890,71 @@
           <a:bodyPr wrap="square" lIns="0" tIns="0" rIns="0" bIns="0" rtlCol="0" anchor="ctr"/>
           <a:lstStyle/>
           <a:p>
+            <a:pPr algn="l">
+              <a:buFont typeface="Arial" panose="020B0604020202020204" pitchFamily="34" charset="0"/>
+              <a:buChar char="•"/>
+            </a:pPr>
+            <a:r>
+              <a:rPr lang="pt-BR" sz="800" b="1" i="0" dirty="0" err="1">
+                <a:solidFill>
+                  <a:srgbClr val="00F2FF"/>
+                </a:solidFill>
+                <a:effectLst/>
+                <a:latin typeface="Poppins" panose="00000500000000000000" pitchFamily="2" charset="0"/>
+              </a:rPr>
+              <a:t>Automated</a:t>
+            </a:r>
+            <a:r>
+              <a:rPr lang="pt-BR" sz="800" b="1" i="0" dirty="0">
+                <a:solidFill>
+                  <a:srgbClr val="00F2FF"/>
+                </a:solidFill>
+                <a:effectLst/>
+                <a:latin typeface="Poppins" panose="00000500000000000000" pitchFamily="2" charset="0"/>
+              </a:rPr>
+              <a:t> Triggers</a:t>
+            </a:r>
+          </a:p>
+          <a:p>
+            <a:pPr algn="l">
+              <a:buFont typeface="Arial" panose="020B0604020202020204" pitchFamily="34" charset="0"/>
+              <a:buChar char="•"/>
+            </a:pPr>
+            <a:r>
+              <a:rPr lang="pt-BR" sz="800" b="0" i="0" dirty="0">
+                <a:solidFill>
+                  <a:srgbClr val="FFFFFF"/>
+                </a:solidFill>
+                <a:effectLst/>
+                <a:latin typeface="Poppins" panose="00000500000000000000" pitchFamily="2" charset="0"/>
+              </a:rPr>
+              <a:t>Scripts podem monitorar </a:t>
+            </a:r>
+            <a:r>
+              <a:rPr lang="pt-BR" sz="800" b="0" i="0" dirty="0" err="1">
+                <a:solidFill>
+                  <a:srgbClr val="FFFFFF"/>
+                </a:solidFill>
+                <a:effectLst/>
+                <a:latin typeface="Poppins" panose="00000500000000000000" pitchFamily="2" charset="0"/>
+              </a:rPr>
+              <a:t>block.timestamp</a:t>
+            </a:r>
+            <a:r>
+              <a:rPr lang="pt-BR" sz="800" b="0" i="0" dirty="0">
+                <a:solidFill>
+                  <a:srgbClr val="FFFFFF"/>
+                </a:solidFill>
+                <a:effectLst/>
+                <a:latin typeface="Poppins" panose="00000500000000000000" pitchFamily="2" charset="0"/>
+              </a:rPr>
+              <a:t> para acionar reembolsos ou pagamentos expirados.</a:t>
+            </a:r>
+          </a:p>
+          <a:p>
             <a:pPr marL="0" indent="0">
               <a:buNone/>
             </a:pPr>
-            <a:r>
-              <a:rPr lang="en-US" sz="900" b="1" dirty="0">
-                <a:solidFill>
-                  <a:srgbClr val="FFFFFF"/>
-                </a:solidFill>
-                <a:latin typeface="Consolas" pitchFamily="34" charset="0"/>
-                <a:ea typeface="Consolas" pitchFamily="34" charset="-122"/>
-                <a:cs typeface="Consolas" pitchFamily="34" charset="-120"/>
-              </a:rPr>
-              <a:t>Approve → Execute → Receipt</a:t>
-            </a:r>
-            <a:endParaRPr lang="en-US" sz="900" dirty="0"/>
-          </a:p>
-        </p:txBody>
-      </p:sp>
-      <p:sp>
-        <p:nvSpPr>
-          <p:cNvPr id="70" name="Text 68"/>
-          <p:cNvSpPr/>
-          <p:nvPr/>
-        </p:nvSpPr>
-        <p:spPr>
-          <a:xfrm>
-            <a:off x="5897880" y="3136392"/>
-            <a:ext cx="2468880" cy="292608"/>
-          </a:xfrm>
-          <a:prstGeom prst="rect">
-            <a:avLst/>
-          </a:prstGeom>
-          <a:noFill/>
-          <a:ln/>
-        </p:spPr>
-        <p:txBody>
-          <a:bodyPr wrap="square" lIns="0" tIns="0" rIns="0" bIns="0" rtlCol="0" anchor="ctr"/>
-          <a:lstStyle/>
-          <a:p>
-            <a:pPr marL="0" indent="0">
-              <a:buNone/>
-            </a:pPr>
-            <a:r>
-              <a:rPr lang="en-US" sz="750" dirty="0">
-                <a:solidFill>
-                  <a:srgbClr val="8B949E"/>
-                </a:solidFill>
-              </a:rPr>
-              <a:t>Fluxo de 3 passos isolado em variáveis de estado local para evitar colisões no cache do Wagmi useWriteContract</a:t>
-            </a:r>
             <a:endParaRPr lang="en-US" sz="750" dirty="0"/>
           </a:p>
         </p:txBody>
@@ -16672,7 +16968,7 @@
         <p:spPr>
           <a:xfrm>
             <a:off x="5806440" y="3529584"/>
-            <a:ext cx="2651760" cy="566928"/>
+            <a:ext cx="2651760" cy="457200"/>
           </a:xfrm>
           <a:prstGeom prst="rect">
             <a:avLst/>
@@ -16696,8 +16992,8 @@
         </p:nvSpPr>
         <p:spPr>
           <a:xfrm>
-            <a:off x="5806440" y="3529584"/>
-            <a:ext cx="36576" cy="566928"/>
+            <a:off x="5806439" y="3529584"/>
+            <a:ext cx="45719" cy="466344"/>
           </a:xfrm>
           <a:prstGeom prst="rect">
             <a:avLst/>
@@ -16715,14 +17011,14 @@
       </p:sp>
       <p:sp>
         <p:nvSpPr>
-          <p:cNvPr id="73" name="Text 71"/>
-          <p:cNvSpPr/>
-          <p:nvPr/>
-        </p:nvSpPr>
-        <p:spPr>
-          <a:xfrm>
-            <a:off x="5897880" y="3575304"/>
-            <a:ext cx="2468880" cy="182880"/>
+          <p:cNvPr id="74" name="Text 72"/>
+          <p:cNvSpPr/>
+          <p:nvPr/>
+        </p:nvSpPr>
+        <p:spPr>
+          <a:xfrm>
+            <a:off x="5875020" y="3617214"/>
+            <a:ext cx="2468880" cy="292608"/>
           </a:xfrm>
           <a:prstGeom prst="rect">
             <a:avLst/>
@@ -16734,57 +17030,73 @@
           <a:bodyPr wrap="square" lIns="0" tIns="0" rIns="0" bIns="0" rtlCol="0" anchor="ctr"/>
           <a:lstStyle/>
           <a:p>
-            <a:pPr marL="0" indent="0">
-              <a:buNone/>
-            </a:pPr>
-            <a:r>
-              <a:rPr lang="en-US" sz="900" b="1" dirty="0">
+            <a:pPr algn="l">
+              <a:buFont typeface="Arial" panose="020B0604020202020204" pitchFamily="34" charset="0"/>
+              <a:buChar char="•"/>
+            </a:pPr>
+            <a:r>
+              <a:rPr lang="pt-BR" sz="800" b="1" i="0" dirty="0">
+                <a:solidFill>
+                  <a:srgbClr val="00F2FF"/>
+                </a:solidFill>
+                <a:effectLst/>
+                <a:latin typeface="Poppins" panose="00000500000000000000" pitchFamily="2" charset="0"/>
+              </a:rPr>
+              <a:t>Logs &amp; </a:t>
+            </a:r>
+            <a:r>
+              <a:rPr lang="pt-BR" sz="800" b="1" i="0" dirty="0" err="1">
+                <a:solidFill>
+                  <a:srgbClr val="00F2FF"/>
+                </a:solidFill>
+                <a:effectLst/>
+                <a:latin typeface="Poppins" panose="00000500000000000000" pitchFamily="2" charset="0"/>
+              </a:rPr>
+              <a:t>Webhooks</a:t>
+            </a:r>
+            <a:endParaRPr lang="pt-BR" sz="800" b="1" i="0" dirty="0">
+              <a:solidFill>
+                <a:srgbClr val="00F2FF"/>
+              </a:solidFill>
+              <a:effectLst/>
+              <a:latin typeface="Poppins" panose="00000500000000000000" pitchFamily="2" charset="0"/>
+            </a:endParaRPr>
+          </a:p>
+          <a:p>
+            <a:pPr algn="l">
+              <a:buFont typeface="Arial" panose="020B0604020202020204" pitchFamily="34" charset="0"/>
+              <a:buChar char="•"/>
+            </a:pPr>
+            <a:r>
+              <a:rPr lang="pt-BR" sz="800" b="0" i="0" dirty="0">
                 <a:solidFill>
                   <a:srgbClr val="FFFFFF"/>
                 </a:solidFill>
-                <a:latin typeface="Consolas" pitchFamily="34" charset="0"/>
-                <a:ea typeface="Consolas" pitchFamily="34" charset="-122"/>
-                <a:cs typeface="Consolas" pitchFamily="34" charset="-120"/>
-              </a:rPr>
-              <a:t>Leitura do Recibo</a:t>
-            </a:r>
-            <a:endParaRPr lang="en-US" sz="900" dirty="0"/>
-          </a:p>
-        </p:txBody>
-      </p:sp>
-      <p:sp>
-        <p:nvSpPr>
-          <p:cNvPr id="74" name="Text 72"/>
-          <p:cNvSpPr/>
-          <p:nvPr/>
-        </p:nvSpPr>
-        <p:spPr>
-          <a:xfrm>
-            <a:off x="5897880" y="3758184"/>
-            <a:ext cx="2468880" cy="292608"/>
-          </a:xfrm>
-          <a:prstGeom prst="rect">
-            <a:avLst/>
-          </a:prstGeom>
-          <a:noFill/>
-          <a:ln/>
-        </p:spPr>
-        <p:txBody>
-          <a:bodyPr wrap="square" lIns="0" tIns="0" rIns="0" bIns="0" rtlCol="0" anchor="ctr"/>
-          <a:lstStyle/>
-          <a:p>
-            <a:pPr marL="0" indent="0">
-              <a:buNone/>
-            </a:pPr>
-            <a:r>
-              <a:rPr lang="en-US" sz="750" dirty="0">
-                <a:solidFill>
-                  <a:srgbClr val="8B949E"/>
-                </a:solidFill>
-              </a:rPr>
-              <a:t>Após o deploy da Factory, o frontend aguarda o transaction receipt e extrai o endereço do Escrow filho dos logs</a:t>
-            </a:r>
-            <a:endParaRPr lang="en-US" sz="750" dirty="0"/>
+                <a:effectLst/>
+                <a:latin typeface="Poppins" panose="00000500000000000000" pitchFamily="2" charset="0"/>
+              </a:rPr>
+              <a:t>Escuta reativa de eventos via RPC para atualização do banco de dados off-</a:t>
+            </a:r>
+            <a:r>
+              <a:rPr lang="pt-BR" sz="800" b="0" i="0" dirty="0" err="1">
+                <a:solidFill>
+                  <a:srgbClr val="FFFFFF"/>
+                </a:solidFill>
+                <a:effectLst/>
+                <a:latin typeface="Poppins" panose="00000500000000000000" pitchFamily="2" charset="0"/>
+              </a:rPr>
+              <a:t>chain</a:t>
+            </a:r>
+            <a:r>
+              <a:rPr lang="pt-BR" sz="800" b="0" i="0" dirty="0">
+                <a:solidFill>
+                  <a:srgbClr val="FFFFFF"/>
+                </a:solidFill>
+                <a:effectLst/>
+                <a:latin typeface="Poppins" panose="00000500000000000000" pitchFamily="2" charset="0"/>
+              </a:rPr>
+              <a:t>.</a:t>
+            </a:r>
           </a:p>
         </p:txBody>
       </p:sp>
@@ -16871,7 +17183,29 @@
                 <a:ea typeface="Consolas" pitchFamily="34" charset="-122"/>
                 <a:cs typeface="Consolas" pitchFamily="34" charset="-120"/>
               </a:rPr>
-              <a:t>Estado síncrono Web2+Web3</a:t>
+              <a:t>Estado </a:t>
+            </a:r>
+            <a:r>
+              <a:rPr lang="en-US" sz="900" b="1" dirty="0" err="1">
+                <a:solidFill>
+                  <a:srgbClr val="FFFFFF"/>
+                </a:solidFill>
+                <a:latin typeface="Consolas" pitchFamily="34" charset="0"/>
+                <a:ea typeface="Consolas" pitchFamily="34" charset="-122"/>
+                <a:cs typeface="Consolas" pitchFamily="34" charset="-120"/>
+              </a:rPr>
+              <a:t>síncrono</a:t>
+            </a:r>
+            <a:r>
+              <a:rPr lang="en-US" sz="900" b="1" dirty="0">
+                <a:solidFill>
+                  <a:srgbClr val="FFFFFF"/>
+                </a:solidFill>
+                <a:latin typeface="Consolas" pitchFamily="34" charset="0"/>
+                <a:ea typeface="Consolas" pitchFamily="34" charset="-122"/>
+                <a:cs typeface="Consolas" pitchFamily="34" charset="-120"/>
+              </a:rPr>
+              <a:t> Web2+Web3</a:t>
             </a:r>
             <a:endParaRPr lang="en-US" sz="900" dirty="0"/>
           </a:p>
@@ -17801,7 +18135,7 @@
         </p:nvSpPr>
         <p:spPr>
           <a:xfrm>
-            <a:off x="7360920" y="1691640"/>
+            <a:off x="7311390" y="1697736"/>
             <a:ext cx="594360" cy="0"/>
           </a:xfrm>
           <a:prstGeom prst="line">
@@ -17824,7 +18158,7 @@
         </p:nvSpPr>
         <p:spPr>
           <a:xfrm>
-            <a:off x="7818120" y="1618488"/>
+            <a:off x="7726680" y="1609344"/>
             <a:ext cx="182880" cy="182880"/>
           </a:xfrm>
           <a:prstGeom prst="rect">
@@ -17860,7 +18194,7 @@
         </p:nvSpPr>
         <p:spPr>
           <a:xfrm>
-            <a:off x="7635240" y="1298448"/>
+            <a:off x="7543800" y="1289304"/>
             <a:ext cx="1554480" cy="777240"/>
           </a:xfrm>
           <a:prstGeom prst="rect">
@@ -17892,7 +18226,7 @@
         </p:nvSpPr>
         <p:spPr>
           <a:xfrm>
-            <a:off x="7635240" y="1298448"/>
+            <a:off x="7543800" y="1298448"/>
             <a:ext cx="1554480" cy="109728"/>
           </a:xfrm>
           <a:prstGeom prst="rect">
@@ -17917,7 +18251,7 @@
         </p:nvSpPr>
         <p:spPr>
           <a:xfrm>
-            <a:off x="7635240" y="1426464"/>
+            <a:off x="7543800" y="1417320"/>
             <a:ext cx="1554480" cy="256032"/>
           </a:xfrm>
           <a:prstGeom prst="rect">
@@ -17953,7 +18287,7 @@
         </p:nvSpPr>
         <p:spPr>
           <a:xfrm>
-            <a:off x="7635240" y="1682496"/>
+            <a:off x="7543800" y="1673352"/>
             <a:ext cx="1554480" cy="365760"/>
           </a:xfrm>
           <a:prstGeom prst="rect">

</xml_diff>